<commit_message>
Use the real demo names
Replaces the placeholder account and stakeholder names with:

  treasurer  عمر الشهراني
  founder    مستور الشهراني
  member     عوض العمري

The names they replace were female, so the gendered Arabic role titles had
to follow: «أمينة الصندوق» becomes «أمين الصندوق» and «قائدة فريق التقنية»
becomes «قائد فريق التقنية». Leaving those would have read as an agreement
error in every place a stakeholder is listed.

Updated at the source — scripts/generate-seed.mjs — then regenerated
data/seed.json, so the names also carry through the audit actors and the
disbursement log. README table and the explainer deck rebuilt to match;
deck revalidated and re-rendered.

Figures are untouched: 4,160 SAR, 982/month, ~4.2 months runway.

Co-Authored-By: Claude Opus 5 <noreply@anthropic.com>
</commit_message>
<xml_diff>
--- a/Monolith-Guide.pptx
+++ b/Monolith-Guide.pptx
@@ -3320,7 +3320,7 @@
                 <a:ea typeface="Arial" pitchFamily="34" charset="-122"/>
                 <a:cs typeface="Arial" pitchFamily="34" charset="-120"/>
               </a:rPr>
-              <a:t>نورة العتيبي</a:t>
+              <a:t>عمر الشهراني</a:t>
             </a:r>
             <a:endParaRPr lang="en-US" sz="1250" dirty="0"/>
           </a:p>
@@ -3362,7 +3362,7 @@
                 <a:ea typeface="Arial" pitchFamily="34" charset="-122"/>
                 <a:cs typeface="Arial" pitchFamily="34" charset="-120"/>
               </a:rPr>
-              <a:t>تعديل نسبة «عبدالرحمن القحطاني»</a:t>
+              <a:t>تعديل نسبة «مستور الشهراني»</a:t>
             </a:r>
             <a:endParaRPr lang="en-US" sz="1200" dirty="0"/>
           </a:p>
@@ -3507,7 +3507,7 @@
                 <a:ea typeface="Arial" pitchFamily="34" charset="-122"/>
                 <a:cs typeface="Arial" pitchFamily="34" charset="-120"/>
               </a:rPr>
-              <a:t>نورة العتيبي</a:t>
+              <a:t>عمر الشهراني</a:t>
             </a:r>
             <a:endParaRPr lang="en-US" sz="1250" dirty="0"/>
           </a:p>
@@ -3694,7 +3694,7 @@
                 <a:ea typeface="Arial" pitchFamily="34" charset="-122"/>
                 <a:cs typeface="Arial" pitchFamily="34" charset="-120"/>
               </a:rPr>
-              <a:t>نورة العتيبي</a:t>
+              <a:t>عمر الشهراني</a:t>
             </a:r>
             <a:endParaRPr lang="en-US" sz="1250" dirty="0"/>
           </a:p>
@@ -4078,7 +4078,7 @@
                 <a:ea typeface="Arial" pitchFamily="34" charset="-122"/>
                 <a:cs typeface="Arial" pitchFamily="34" charset="-120"/>
               </a:rPr>
-              <a:t>نورة العتيبي</a:t>
+              <a:t>عمر الشهراني</a:t>
             </a:r>
             <a:endParaRPr lang="en-US" sz="1700" dirty="0"/>
           </a:p>
@@ -4223,7 +4223,7 @@
                 <a:ea typeface="Arial" pitchFamily="34" charset="-122"/>
                 <a:cs typeface="Arial" pitchFamily="34" charset="-120"/>
               </a:rPr>
-              <a:t>عبدالرحمن القحطاني</a:t>
+              <a:t>مستور الشهراني</a:t>
             </a:r>
             <a:endParaRPr lang="en-US" sz="1700" dirty="0"/>
           </a:p>
@@ -4368,7 +4368,7 @@
                 <a:ea typeface="Arial" pitchFamily="34" charset="-122"/>
                 <a:cs typeface="Arial" pitchFamily="34" charset="-120"/>
               </a:rPr>
-              <a:t>ريم الدوسري</a:t>
+              <a:t>عوض العمري</a:t>
             </a:r>
             <a:endParaRPr lang="en-US" sz="1700" dirty="0"/>
           </a:p>
@@ -9589,7 +9589,7 @@
                 <a:ea typeface="Arial" pitchFamily="34" charset="-122"/>
                 <a:cs typeface="Arial" pitchFamily="34" charset="-120"/>
               </a:rPr>
-              <a:t>عبدالرحمن القحطاني</a:t>
+              <a:t>مستور الشهراني</a:t>
             </a:r>
             <a:endParaRPr lang="en-US" sz="1250" dirty="0"/>
           </a:p>
@@ -9670,7 +9670,7 @@
                 <a:ea typeface="Arial" pitchFamily="34" charset="-122"/>
                 <a:cs typeface="Arial" pitchFamily="34" charset="-120"/>
               </a:rPr>
-              <a:t>نورة العتيبي</a:t>
+              <a:t>عمر الشهراني</a:t>
             </a:r>
             <a:endParaRPr lang="en-US" sz="1250" dirty="0"/>
           </a:p>
@@ -9751,7 +9751,7 @@
                 <a:ea typeface="Arial" pitchFamily="34" charset="-122"/>
                 <a:cs typeface="Arial" pitchFamily="34" charset="-120"/>
               </a:rPr>
-              <a:t>ريم الدوسري</a:t>
+              <a:t>عوض العمري</a:t>
             </a:r>
             <a:endParaRPr lang="en-US" sz="1250" dirty="0"/>
           </a:p>

</xml_diff>